<commit_message>
Replace questions slide with thank-you slide
</commit_message>
<xml_diff>
--- a/docs/healthcare-pipeline-demo.pptx
+++ b/docs/healthcare-pipeline-demo.pptx
@@ -116,12 +116,12 @@
   <p:extLst>
     <p:ext uri="{521415D9-36F7-43E2-AB2F-B90AF26B5E84}">
       <p14:sectionLst xmlns:p14="http://schemas.microsoft.com/office/powerpoint/2010/main">
-        <p14:section name="Opening" id="{dcdb4874-897f-ab40-688d-3f355f7a8e22}">
+        <p14:section name="Opening" id="{f5cd304d-6f82-d330-fbed-770c0d955c42}">
           <p14:sldIdLst>
             <p14:sldId id="256"/>
           </p14:sldIdLst>
         </p14:section>
-        <p14:section name="Demo" id="{6d9684d7-0cd6-406c-d747-5a8073b7699f}">
+        <p14:section name="Demo" id="{7c6ab19a-7f3a-a4a7-85a8-f510c5a8730f}">
           <p14:sldIdLst>
             <p14:sldId id="257"/>
             <p14:sldId id="258"/>
@@ -132,7 +132,7 @@
             <p14:sldId id="263"/>
           </p14:sldIdLst>
         </p14:section>
-        <p14:section name="Close" id="{c773e553-850b-9f8d-7cb5-d723710660ce}">
+        <p14:section name="Close" id="{c58de793-eaad-6d63-9aaa-a47d21f0cd29}">
           <p14:sldIdLst>
             <p14:sldId id="264"/>
             <p14:sldId id="265"/>
@@ -630,7 +630,7 @@
           <a:p>
             <a:r>
               <a:rPr lang="en-US" dirty="0"/>
-              <a:t>Be ready to say that MySQL is configured as a profile but only H2 was tested.</a:t>
+              <a:t>Thank you. Happy to take questions.</a:t>
             </a:r>
             <a:endParaRPr lang="en-US" dirty="0"/>
           </a:p>
@@ -2143,14 +2143,50 @@
       </p:grpSpPr>
       <p:sp>
         <p:nvSpPr>
-          <p:cNvPr id="2" name="Section label"/>
-          <p:cNvSpPr txBox="1"/>
-          <p:nvPr/>
-        </p:nvSpPr>
-        <p:spPr>
-          <a:xfrm>
-            <a:off x="502920" y="320040"/>
-            <a:ext cx="8138160" cy="274320"/>
+          <p:cNvPr id="2" name="Label"/>
+          <p:cNvSpPr txBox="1"/>
+          <p:nvPr/>
+        </p:nvSpPr>
+        <p:spPr>
+          <a:xfrm>
+            <a:off x="640080" y="1463040"/>
+            <a:ext cx="7863840" cy="274320"/>
+          </a:xfrm>
+          <a:prstGeom prst="rect">
+            <a:avLst/>
+          </a:prstGeom>
+          <a:noFill/>
+          <a:ln/>
+        </p:spPr>
+        <p:txBody>
+          <a:bodyPr wrap="square" lIns="0" tIns="0" rIns="0" bIns="0" rtlCol="0" anchor="ctr"/>
+          <a:lstStyle/>
+          <a:p>
+            <a:pPr indent="0" marL="0">
+              <a:buNone/>
+            </a:pPr>
+            <a:r>
+              <a:rPr lang="en-US" sz="1200" b="1" spc="100" kern="0" dirty="0">
+                <a:solidFill>
+                  <a:schemeClr val="accent2"/>
+                </a:solidFill>
+              </a:rPr>
+              <a:t>THANK YOU</a:t>
+            </a:r>
+            <a:endParaRPr lang="en-US" sz="1200" dirty="0"/>
+          </a:p>
+        </p:txBody>
+      </p:sp>
+      <p:sp>
+        <p:nvSpPr>
+          <p:cNvPr id="3" name="Title"/>
+          <p:cNvSpPr txBox="1"/>
+          <p:nvPr/>
+        </p:nvSpPr>
+        <p:spPr>
+          <a:xfrm>
+            <a:off x="640080" y="1783080"/>
+            <a:ext cx="7863840" cy="822960"/>
           </a:xfrm>
           <a:prstGeom prst="rect">
             <a:avLst/>
@@ -2166,150 +2202,120 @@
               <a:buNone/>
             </a:pPr>
             <a:r>
-              <a:rPr lang="en-US" sz="1100" b="1" spc="100" kern="0" dirty="0">
-                <a:solidFill>
-                  <a:schemeClr val="accent1"/>
-                </a:solidFill>
-              </a:rPr>
-              <a:t>VIVA PREPARATION</a:t>
-            </a:r>
-            <a:endParaRPr lang="en-US" sz="1100" dirty="0"/>
-          </a:p>
-        </p:txBody>
-      </p:sp>
-      <p:sp>
-        <p:nvSpPr>
-          <p:cNvPr id="3" name="Slide title"/>
-          <p:cNvSpPr txBox="1"/>
-          <p:nvPr/>
-        </p:nvSpPr>
-        <p:spPr>
-          <a:xfrm>
-            <a:off x="502920" y="594360"/>
-            <a:ext cx="8138160" cy="594360"/>
-          </a:xfrm>
-          <a:prstGeom prst="rect">
-            <a:avLst/>
-          </a:prstGeom>
-          <a:noFill/>
-          <a:ln/>
-        </p:spPr>
-        <p:txBody>
-          <a:bodyPr wrap="square" lIns="0" tIns="0" rIns="0" bIns="0" rtlCol="0" anchor="t"/>
-          <a:lstStyle/>
-          <a:p>
-            <a:pPr indent="0" marL="0">
-              <a:buNone/>
-            </a:pPr>
-            <a:r>
-              <a:rPr lang="en-US" sz="3000" b="1" dirty="0">
-                <a:solidFill>
-                  <a:schemeClr val="tx1"/>
-                </a:solidFill>
-              </a:rPr>
-              <a:t>Likely Questions</a:t>
-            </a:r>
-            <a:endParaRPr lang="en-US" sz="3000" dirty="0"/>
-          </a:p>
-        </p:txBody>
-      </p:sp>
-      <p:sp>
-        <p:nvSpPr>
-          <p:cNvPr id="5" name="Why a queue? card"/>
-          <p:cNvSpPr/>
-          <p:nvPr/>
-        </p:nvSpPr>
-        <p:spPr>
-          <a:xfrm>
-            <a:off x="502920" y="1417320"/>
-            <a:ext cx="3931920" cy="1463040"/>
-          </a:xfrm>
-          <a:prstGeom prst="roundRect">
-            <a:avLst>
-              <a:gd name="adj" fmla="val 5000"/>
-            </a:avLst>
-          </a:prstGeom>
-          <a:solidFill>
-            <a:schemeClr val="bg2"/>
-          </a:solidFill>
-          <a:ln w="12700">
-            <a:solidFill>
-              <a:schemeClr val="accent4"/>
-            </a:solidFill>
-            <a:prstDash val="solid"/>
-          </a:ln>
-        </p:spPr>
-      </p:sp>
-      <p:sp>
-        <p:nvSpPr>
-          <p:cNvPr id="6" name="Why a queue? heading"/>
-          <p:cNvSpPr txBox="1"/>
-          <p:nvPr/>
-        </p:nvSpPr>
-        <p:spPr>
-          <a:xfrm>
-            <a:off x="704088" y="1563624"/>
-            <a:ext cx="3529584" cy="365760"/>
-          </a:xfrm>
-          <a:prstGeom prst="rect">
-            <a:avLst/>
-          </a:prstGeom>
-          <a:noFill/>
-          <a:ln/>
-        </p:spPr>
-        <p:txBody>
-          <a:bodyPr wrap="square" lIns="0" tIns="0" rIns="0" bIns="0" rtlCol="0" anchor="t"/>
-          <a:lstStyle/>
-          <a:p>
-            <a:pPr indent="0" marL="0">
-              <a:buNone/>
-            </a:pPr>
-            <a:r>
-              <a:rPr lang="en-US" sz="1700" b="1" dirty="0">
-                <a:solidFill>
-                  <a:schemeClr val="accent1"/>
-                </a:solidFill>
-              </a:rPr>
-              <a:t>Why a queue?</a:t>
-            </a:r>
-            <a:endParaRPr lang="en-US" sz="1700" dirty="0"/>
-          </a:p>
-        </p:txBody>
-      </p:sp>
-      <p:sp>
-        <p:nvSpPr>
-          <p:cNvPr id="7" name="Why a queue? body"/>
-          <p:cNvSpPr txBox="1"/>
-          <p:nvPr/>
-        </p:nvSpPr>
-        <p:spPr>
-          <a:xfrm>
-            <a:off x="704088" y="1965960"/>
-            <a:ext cx="3529584" cy="777240"/>
-          </a:xfrm>
-          <a:prstGeom prst="rect">
-            <a:avLst/>
-          </a:prstGeom>
-          <a:noFill/>
-          <a:ln/>
-        </p:spPr>
-        <p:txBody>
-          <a:bodyPr wrap="square" lIns="0" tIns="0" rIns="0" bIns="0" rtlCol="0" anchor="t"/>
-          <a:lstStyle/>
-          <a:p>
-            <a:pPr indent="0" marL="0">
-              <a:spcAft>
-                <a:spcPts val="500"/>
-              </a:spcAft>
-              <a:buNone/>
-            </a:pPr>
-            <a:r>
-              <a:rPr lang="en-US" sz="1500" dirty="0">
-                <a:solidFill>
-                  <a:schemeClr val="tx1"/>
-                </a:solidFill>
-              </a:rPr>
-              <a:t>It keeps HTTP threads free during spikes and survives slow external services.</a:t>
+              <a:rPr lang="en-US" sz="4800" b="1" dirty="0">
+                <a:solidFill>
+                  <a:schemeClr val="bg1"/>
+                </a:solidFill>
+              </a:rPr>
+              <a:t>Thank you</a:t>
+            </a:r>
+            <a:endParaRPr lang="en-US" sz="4800" dirty="0"/>
+          </a:p>
+        </p:txBody>
+      </p:sp>
+      <p:sp>
+        <p:nvSpPr>
+          <p:cNvPr id="4" name="Subtitle"/>
+          <p:cNvSpPr txBox="1"/>
+          <p:nvPr/>
+        </p:nvSpPr>
+        <p:spPr>
+          <a:xfrm>
+            <a:off x="640080" y="2697480"/>
+            <a:ext cx="7863840" cy="365760"/>
+          </a:xfrm>
+          <a:prstGeom prst="rect">
+            <a:avLst/>
+          </a:prstGeom>
+          <a:noFill/>
+          <a:ln/>
+        </p:spPr>
+        <p:txBody>
+          <a:bodyPr wrap="square" lIns="0" tIns="0" rIns="0" bIns="0" rtlCol="0" anchor="ctr"/>
+          <a:lstStyle/>
+          <a:p>
+            <a:pPr indent="0" marL="0">
+              <a:buNone/>
+            </a:pPr>
+            <a:r>
+              <a:rPr lang="en-US" sz="1600" dirty="0">
+                <a:solidFill>
+                  <a:schemeClr val="accent6"/>
+                </a:solidFill>
+              </a:rPr>
+              <a:t>Healthcare Appointment Scheduling and Lab Result Pipeline</a:t>
+            </a:r>
+            <a:endParaRPr lang="en-US" sz="1600" dirty="0"/>
+          </a:p>
+        </p:txBody>
+      </p:sp>
+      <p:sp>
+        <p:nvSpPr>
+          <p:cNvPr id="5" name="NAME label"/>
+          <p:cNvSpPr txBox="1"/>
+          <p:nvPr/>
+        </p:nvSpPr>
+        <p:spPr>
+          <a:xfrm>
+            <a:off x="640080" y="3840480"/>
+            <a:ext cx="2103120" cy="228600"/>
+          </a:xfrm>
+          <a:prstGeom prst="rect">
+            <a:avLst/>
+          </a:prstGeom>
+          <a:noFill/>
+          <a:ln/>
+        </p:spPr>
+        <p:txBody>
+          <a:bodyPr wrap="square" lIns="0" tIns="0" rIns="0" bIns="0" rtlCol="0" anchor="ctr"/>
+          <a:lstStyle/>
+          <a:p>
+            <a:pPr indent="0" marL="0">
+              <a:buNone/>
+            </a:pPr>
+            <a:r>
+              <a:rPr lang="en-US" sz="1000" b="1" dirty="0">
+                <a:solidFill>
+                  <a:schemeClr val="accent6"/>
+                </a:solidFill>
+              </a:rPr>
+              <a:t>NAME</a:t>
+            </a:r>
+            <a:endParaRPr lang="en-US" sz="1000" dirty="0"/>
+          </a:p>
+        </p:txBody>
+      </p:sp>
+      <p:sp>
+        <p:nvSpPr>
+          <p:cNvPr id="6" name="NAME value"/>
+          <p:cNvSpPr txBox="1"/>
+          <p:nvPr/>
+        </p:nvSpPr>
+        <p:spPr>
+          <a:xfrm>
+            <a:off x="640080" y="4069080"/>
+            <a:ext cx="2103120" cy="320040"/>
+          </a:xfrm>
+          <a:prstGeom prst="rect">
+            <a:avLst/>
+          </a:prstGeom>
+          <a:noFill/>
+          <a:ln/>
+        </p:spPr>
+        <p:txBody>
+          <a:bodyPr wrap="square" lIns="0" tIns="0" rIns="0" bIns="0" rtlCol="0" anchor="ctr"/>
+          <a:lstStyle/>
+          <a:p>
+            <a:pPr indent="0" marL="0">
+              <a:buNone/>
+            </a:pPr>
+            <a:r>
+              <a:rPr lang="en-US" sz="1500" b="1" dirty="0">
+                <a:solidFill>
+                  <a:schemeClr val="bg1"/>
+                </a:solidFill>
+              </a:rPr>
+              <a:t>Ballini Soundarya M</a:t>
             </a:r>
             <a:endParaRPr lang="en-US" sz="1500" dirty="0"/>
           </a:p>
@@ -2317,101 +2323,71 @@
       </p:sp>
       <p:sp>
         <p:nvSpPr>
-          <p:cNvPr id="8" name="Why optimistic locking? card"/>
-          <p:cNvSpPr/>
-          <p:nvPr/>
-        </p:nvSpPr>
-        <p:spPr>
-          <a:xfrm>
-            <a:off x="4709160" y="1417320"/>
-            <a:ext cx="3931920" cy="1463040"/>
-          </a:xfrm>
-          <a:prstGeom prst="roundRect">
-            <a:avLst>
-              <a:gd name="adj" fmla="val 5000"/>
-            </a:avLst>
-          </a:prstGeom>
-          <a:solidFill>
-            <a:schemeClr val="bg2"/>
-          </a:solidFill>
-          <a:ln w="12700">
-            <a:solidFill>
-              <a:schemeClr val="accent4"/>
-            </a:solidFill>
-            <a:prstDash val="solid"/>
-          </a:ln>
-        </p:spPr>
-      </p:sp>
-      <p:sp>
-        <p:nvSpPr>
-          <p:cNvPr id="9" name="Why optimistic locking? heading"/>
-          <p:cNvSpPr txBox="1"/>
-          <p:nvPr/>
-        </p:nvSpPr>
-        <p:spPr>
-          <a:xfrm>
-            <a:off x="4910328" y="1563624"/>
-            <a:ext cx="3529584" cy="365760"/>
-          </a:xfrm>
-          <a:prstGeom prst="rect">
-            <a:avLst/>
-          </a:prstGeom>
-          <a:noFill/>
-          <a:ln/>
-        </p:spPr>
-        <p:txBody>
-          <a:bodyPr wrap="square" lIns="0" tIns="0" rIns="0" bIns="0" rtlCol="0" anchor="t"/>
-          <a:lstStyle/>
-          <a:p>
-            <a:pPr indent="0" marL="0">
-              <a:buNone/>
-            </a:pPr>
-            <a:r>
-              <a:rPr lang="en-US" sz="1700" b="1" dirty="0">
-                <a:solidFill>
-                  <a:schemeClr val="accent1"/>
-                </a:solidFill>
-              </a:rPr>
-              <a:t>Why optimistic locking?</a:t>
-            </a:r>
-            <a:endParaRPr lang="en-US" sz="1700" dirty="0"/>
-          </a:p>
-        </p:txBody>
-      </p:sp>
-      <p:sp>
-        <p:nvSpPr>
-          <p:cNvPr id="10" name="Why optimistic locking? body"/>
-          <p:cNvSpPr txBox="1"/>
-          <p:nvPr/>
-        </p:nvSpPr>
-        <p:spPr>
-          <a:xfrm>
-            <a:off x="4910328" y="1965960"/>
-            <a:ext cx="3529584" cy="777240"/>
-          </a:xfrm>
-          <a:prstGeom prst="rect">
-            <a:avLst/>
-          </a:prstGeom>
-          <a:noFill/>
-          <a:ln/>
-        </p:spPr>
-        <p:txBody>
-          <a:bodyPr wrap="square" lIns="0" tIns="0" rIns="0" bIns="0" rtlCol="0" anchor="t"/>
-          <a:lstStyle/>
-          <a:p>
-            <a:pPr indent="0" marL="0">
-              <a:spcAft>
-                <a:spcPts val="500"/>
-              </a:spcAft>
-              <a:buNone/>
-            </a:pPr>
-            <a:r>
-              <a:rPr lang="en-US" sz="1500" dirty="0">
-                <a:solidFill>
-                  <a:schemeClr val="tx1"/>
-                </a:solidFill>
-              </a:rPr>
-              <a:t>Conflicts are rare and no table is locked; a conflict is detected at save time.</a:t>
+          <p:cNvPr id="7" name="REGISTRATION NUMBER label"/>
+          <p:cNvSpPr txBox="1"/>
+          <p:nvPr/>
+        </p:nvSpPr>
+        <p:spPr>
+          <a:xfrm>
+            <a:off x="3017520" y="3840480"/>
+            <a:ext cx="2011680" cy="228600"/>
+          </a:xfrm>
+          <a:prstGeom prst="rect">
+            <a:avLst/>
+          </a:prstGeom>
+          <a:noFill/>
+          <a:ln/>
+        </p:spPr>
+        <p:txBody>
+          <a:bodyPr wrap="square" lIns="0" tIns="0" rIns="0" bIns="0" rtlCol="0" anchor="ctr"/>
+          <a:lstStyle/>
+          <a:p>
+            <a:pPr indent="0" marL="0">
+              <a:buNone/>
+            </a:pPr>
+            <a:r>
+              <a:rPr lang="en-US" sz="1000" b="1" dirty="0">
+                <a:solidFill>
+                  <a:schemeClr val="accent6"/>
+                </a:solidFill>
+              </a:rPr>
+              <a:t>REGISTRATION NUMBER</a:t>
+            </a:r>
+            <a:endParaRPr lang="en-US" sz="1000" dirty="0"/>
+          </a:p>
+        </p:txBody>
+      </p:sp>
+      <p:sp>
+        <p:nvSpPr>
+          <p:cNvPr id="8" name="REGISTRATION NUMBER value"/>
+          <p:cNvSpPr txBox="1"/>
+          <p:nvPr/>
+        </p:nvSpPr>
+        <p:spPr>
+          <a:xfrm>
+            <a:off x="3017520" y="4069080"/>
+            <a:ext cx="2011680" cy="320040"/>
+          </a:xfrm>
+          <a:prstGeom prst="rect">
+            <a:avLst/>
+          </a:prstGeom>
+          <a:noFill/>
+          <a:ln/>
+        </p:spPr>
+        <p:txBody>
+          <a:bodyPr wrap="square" lIns="0" tIns="0" rIns="0" bIns="0" rtlCol="0" anchor="ctr"/>
+          <a:lstStyle/>
+          <a:p>
+            <a:pPr indent="0" marL="0">
+              <a:buNone/>
+            </a:pPr>
+            <a:r>
+              <a:rPr lang="en-US" sz="1500" b="1" dirty="0">
+                <a:solidFill>
+                  <a:schemeClr val="bg1"/>
+                </a:solidFill>
+              </a:rPr>
+              <a:t>24MIC0026</a:t>
             </a:r>
             <a:endParaRPr lang="en-US" sz="1500" dirty="0"/>
           </a:p>
@@ -2419,203 +2395,71 @@
       </p:sp>
       <p:sp>
         <p:nvSpPr>
-          <p:cNvPr id="11" name="Which database? card"/>
-          <p:cNvSpPr/>
-          <p:nvPr/>
-        </p:nvSpPr>
-        <p:spPr>
-          <a:xfrm>
-            <a:off x="502920" y="3017520"/>
-            <a:ext cx="3931920" cy="1463040"/>
-          </a:xfrm>
-          <a:prstGeom prst="roundRect">
-            <a:avLst>
-              <a:gd name="adj" fmla="val 5000"/>
-            </a:avLst>
-          </a:prstGeom>
-          <a:solidFill>
-            <a:schemeClr val="bg2"/>
-          </a:solidFill>
-          <a:ln w="12700">
-            <a:solidFill>
-              <a:schemeClr val="accent4"/>
-            </a:solidFill>
-            <a:prstDash val="solid"/>
-          </a:ln>
-        </p:spPr>
-      </p:sp>
-      <p:sp>
-        <p:nvSpPr>
-          <p:cNvPr id="12" name="Which database? heading"/>
-          <p:cNvSpPr txBox="1"/>
-          <p:nvPr/>
-        </p:nvSpPr>
-        <p:spPr>
-          <a:xfrm>
-            <a:off x="704088" y="3163824"/>
-            <a:ext cx="3529584" cy="365760"/>
-          </a:xfrm>
-          <a:prstGeom prst="rect">
-            <a:avLst/>
-          </a:prstGeom>
-          <a:noFill/>
-          <a:ln/>
-        </p:spPr>
-        <p:txBody>
-          <a:bodyPr wrap="square" lIns="0" tIns="0" rIns="0" bIns="0" rtlCol="0" anchor="t"/>
-          <a:lstStyle/>
-          <a:p>
-            <a:pPr indent="0" marL="0">
-              <a:buNone/>
-            </a:pPr>
-            <a:r>
-              <a:rPr lang="en-US" sz="1700" b="1" dirty="0">
-                <a:solidFill>
-                  <a:schemeClr val="accent1"/>
-                </a:solidFill>
-              </a:rPr>
-              <a:t>Which database?</a:t>
-            </a:r>
-            <a:endParaRPr lang="en-US" sz="1700" dirty="0"/>
-          </a:p>
-        </p:txBody>
-      </p:sp>
-      <p:sp>
-        <p:nvSpPr>
-          <p:cNvPr id="13" name="Which database? body"/>
-          <p:cNvSpPr txBox="1"/>
-          <p:nvPr/>
-        </p:nvSpPr>
-        <p:spPr>
-          <a:xfrm>
-            <a:off x="704088" y="3566160"/>
-            <a:ext cx="3529584" cy="777240"/>
-          </a:xfrm>
-          <a:prstGeom prst="rect">
-            <a:avLst/>
-          </a:prstGeom>
-          <a:noFill/>
-          <a:ln/>
-        </p:spPr>
-        <p:txBody>
-          <a:bodyPr wrap="square" lIns="0" tIns="0" rIns="0" bIns="0" rtlCol="0" anchor="t"/>
-          <a:lstStyle/>
-          <a:p>
-            <a:pPr indent="0" marL="0">
-              <a:spcAft>
-                <a:spcPts val="500"/>
-              </a:spcAft>
-              <a:buNone/>
-            </a:pPr>
-            <a:r>
-              <a:rPr lang="en-US" sz="1500" dirty="0">
-                <a:solidFill>
-                  <a:schemeClr val="tx1"/>
-                </a:solidFill>
-              </a:rPr>
-              <a:t>H2 in memory for the demo, with a MySQL profile configured but only H2 tested.</a:t>
-            </a:r>
-            <a:endParaRPr lang="en-US" sz="1500" dirty="0"/>
-          </a:p>
-        </p:txBody>
-      </p:sp>
-      <p:sp>
-        <p:nvSpPr>
-          <p:cNvPr id="14" name="What happens on restart? card"/>
-          <p:cNvSpPr/>
-          <p:nvPr/>
-        </p:nvSpPr>
-        <p:spPr>
-          <a:xfrm>
-            <a:off x="4709160" y="3017520"/>
-            <a:ext cx="3931920" cy="1463040"/>
-          </a:xfrm>
-          <a:prstGeom prst="roundRect">
-            <a:avLst>
-              <a:gd name="adj" fmla="val 5000"/>
-            </a:avLst>
-          </a:prstGeom>
-          <a:solidFill>
-            <a:schemeClr val="bg2"/>
-          </a:solidFill>
-          <a:ln w="12700">
-            <a:solidFill>
-              <a:schemeClr val="accent4"/>
-            </a:solidFill>
-            <a:prstDash val="solid"/>
-          </a:ln>
-        </p:spPr>
-      </p:sp>
-      <p:sp>
-        <p:nvSpPr>
-          <p:cNvPr id="15" name="What happens on restart? heading"/>
-          <p:cNvSpPr txBox="1"/>
-          <p:nvPr/>
-        </p:nvSpPr>
-        <p:spPr>
-          <a:xfrm>
-            <a:off x="4910328" y="3163824"/>
-            <a:ext cx="3529584" cy="365760"/>
-          </a:xfrm>
-          <a:prstGeom prst="rect">
-            <a:avLst/>
-          </a:prstGeom>
-          <a:noFill/>
-          <a:ln/>
-        </p:spPr>
-        <p:txBody>
-          <a:bodyPr wrap="square" lIns="0" tIns="0" rIns="0" bIns="0" rtlCol="0" anchor="t"/>
-          <a:lstStyle/>
-          <a:p>
-            <a:pPr indent="0" marL="0">
-              <a:buNone/>
-            </a:pPr>
-            <a:r>
-              <a:rPr lang="en-US" sz="1700" b="1" dirty="0">
-                <a:solidFill>
-                  <a:schemeClr val="accent1"/>
-                </a:solidFill>
-              </a:rPr>
-              <a:t>What happens on restart?</a:t>
-            </a:r>
-            <a:endParaRPr lang="en-US" sz="1700" dirty="0"/>
-          </a:p>
-        </p:txBody>
-      </p:sp>
-      <p:sp>
-        <p:nvSpPr>
-          <p:cNvPr id="16" name="What happens on restart? body"/>
-          <p:cNvSpPr txBox="1"/>
-          <p:nvPr/>
-        </p:nvSpPr>
-        <p:spPr>
-          <a:xfrm>
-            <a:off x="4910328" y="3566160"/>
-            <a:ext cx="3529584" cy="777240"/>
-          </a:xfrm>
-          <a:prstGeom prst="rect">
-            <a:avLst/>
-          </a:prstGeom>
-          <a:noFill/>
-          <a:ln/>
-        </p:spPr>
-        <p:txBody>
-          <a:bodyPr wrap="square" lIns="0" tIns="0" rIns="0" bIns="0" rtlCol="0" anchor="t"/>
-          <a:lstStyle/>
-          <a:p>
-            <a:pPr indent="0" marL="0">
-              <a:spcAft>
-                <a:spcPts val="500"/>
-              </a:spcAft>
-              <a:buNone/>
-            </a:pPr>
-            <a:r>
-              <a:rPr lang="en-US" sz="1500" dirty="0">
-                <a:solidFill>
-                  <a:schemeClr val="tx1"/>
-                </a:solidFill>
-              </a:rPr>
-              <a:t>The demo data resets because it is in memory; MySQL would keep it.</a:t>
+          <p:cNvPr id="9" name="COURSE label"/>
+          <p:cNvSpPr txBox="1"/>
+          <p:nvPr/>
+        </p:nvSpPr>
+        <p:spPr>
+          <a:xfrm>
+            <a:off x="4937760" y="3840480"/>
+            <a:ext cx="3749040" cy="228600"/>
+          </a:xfrm>
+          <a:prstGeom prst="rect">
+            <a:avLst/>
+          </a:prstGeom>
+          <a:noFill/>
+          <a:ln/>
+        </p:spPr>
+        <p:txBody>
+          <a:bodyPr wrap="square" lIns="0" tIns="0" rIns="0" bIns="0" rtlCol="0" anchor="ctr"/>
+          <a:lstStyle/>
+          <a:p>
+            <a:pPr indent="0" marL="0">
+              <a:buNone/>
+            </a:pPr>
+            <a:r>
+              <a:rPr lang="en-US" sz="1000" b="1" dirty="0">
+                <a:solidFill>
+                  <a:schemeClr val="accent6"/>
+                </a:solidFill>
+              </a:rPr>
+              <a:t>COURSE</a:t>
+            </a:r>
+            <a:endParaRPr lang="en-US" sz="1000" dirty="0"/>
+          </a:p>
+        </p:txBody>
+      </p:sp>
+      <p:sp>
+        <p:nvSpPr>
+          <p:cNvPr id="10" name="COURSE value"/>
+          <p:cNvSpPr txBox="1"/>
+          <p:nvPr/>
+        </p:nvSpPr>
+        <p:spPr>
+          <a:xfrm>
+            <a:off x="4937760" y="4069080"/>
+            <a:ext cx="3749040" cy="320040"/>
+          </a:xfrm>
+          <a:prstGeom prst="rect">
+            <a:avLst/>
+          </a:prstGeom>
+          <a:noFill/>
+          <a:ln/>
+        </p:spPr>
+        <p:txBody>
+          <a:bodyPr wrap="square" lIns="0" tIns="0" rIns="0" bIns="0" rtlCol="0" anchor="ctr"/>
+          <a:lstStyle/>
+          <a:p>
+            <a:pPr indent="0" marL="0">
+              <a:buNone/>
+            </a:pPr>
+            <a:r>
+              <a:rPr lang="en-US" sz="1500" b="1" dirty="0">
+                <a:solidFill>
+                  <a:schemeClr val="accent2"/>
+                </a:solidFill>
+              </a:rPr>
+              <a:t>Advanced Server Side Programming</a:t>
             </a:r>
             <a:endParaRPr lang="en-US" sz="1500" dirty="0"/>
           </a:p>

</xml_diff>